<commit_message>
Manuel expert : remplace les numéros de page par des liens « Voir → »
Co-Authored-By: Claude Sonnet 5.5 <noreply@anthropic.com>
Claude-Session: https://claude.ai/code/session_01DfX8WMiDGRydEV8tsLY6TE
</commit_message>
<xml_diff>
--- a/docs/Manuel_Project_Navigator_expert.pptx
+++ b/docs/Manuel_Project_Navigator_expert.pptx
@@ -24196,7 +24196,7 @@
           <a:lstStyle/>
           <a:p>
             <a:r>
-              <a:t>5</a:t>
+              <a:t>→</a:t>
             </a:r>
           </a:p>
         </p:txBody>
@@ -24242,7 +24242,7 @@
           <a:lstStyle/>
           <a:p>
             <a:r>
-              <a:t>9</a:t>
+              <a:t>→</a:t>
             </a:r>
           </a:p>
         </p:txBody>
@@ -24288,7 +24288,7 @@
           <a:lstStyle/>
           <a:p>
             <a:r>
-              <a:t>14</a:t>
+              <a:t>→</a:t>
             </a:r>
           </a:p>
         </p:txBody>
@@ -24334,7 +24334,7 @@
           <a:lstStyle/>
           <a:p>
             <a:r>
-              <a:t>19</a:t>
+              <a:t>→</a:t>
             </a:r>
           </a:p>
         </p:txBody>
@@ -24380,7 +24380,7 @@
           <a:lstStyle/>
           <a:p>
             <a:r>
-              <a:t>24</a:t>
+              <a:t>→</a:t>
             </a:r>
           </a:p>
         </p:txBody>
@@ -24426,7 +24426,7 @@
           <a:lstStyle/>
           <a:p>
             <a:r>
-              <a:t>26</a:t>
+              <a:t>→</a:t>
             </a:r>
           </a:p>
         </p:txBody>
@@ -24472,7 +24472,7 @@
           <a:lstStyle/>
           <a:p>
             <a:r>
-              <a:t>37</a:t>
+              <a:t>→</a:t>
             </a:r>
           </a:p>
         </p:txBody>
@@ -28930,7 +28930,7 @@
                 </a:solidFill>
                 <a:latin typeface="Roboto"/>
               </a:rPr>
-              <a:t>Page</a:t>
+              <a:t>Lien</a:t>
             </a:r>
           </a:p>
         </p:txBody>
@@ -29083,7 +29083,7 @@
                 </a:solidFill>
                 <a:latin typeface="Roboto"/>
               </a:rPr>
-              <a:t>6</a:t>
+              <a:t>Voir →</a:t>
             </a:r>
           </a:p>
         </p:txBody>
@@ -29192,7 +29192,7 @@
                 </a:solidFill>
                 <a:latin typeface="Roboto"/>
               </a:rPr>
-              <a:t>7</a:t>
+              <a:t>Voir →</a:t>
             </a:r>
           </a:p>
         </p:txBody>
@@ -29345,7 +29345,7 @@
                 </a:solidFill>
                 <a:latin typeface="Roboto"/>
               </a:rPr>
-              <a:t>7</a:t>
+              <a:t>Voir →</a:t>
             </a:r>
           </a:p>
         </p:txBody>
@@ -29454,7 +29454,7 @@
                 </a:solidFill>
                 <a:latin typeface="Roboto"/>
               </a:rPr>
-              <a:t>7</a:t>
+              <a:t>Voir →</a:t>
             </a:r>
           </a:p>
         </p:txBody>
@@ -29607,7 +29607,7 @@
                 </a:solidFill>
                 <a:latin typeface="Roboto"/>
               </a:rPr>
-              <a:t>11</a:t>
+              <a:t>Voir →</a:t>
             </a:r>
           </a:p>
         </p:txBody>
@@ -29716,7 +29716,7 @@
                 </a:solidFill>
                 <a:latin typeface="Roboto"/>
               </a:rPr>
-              <a:t>15</a:t>
+              <a:t>Voir →</a:t>
             </a:r>
           </a:p>
         </p:txBody>
@@ -29869,7 +29869,7 @@
                 </a:solidFill>
                 <a:latin typeface="Roboto"/>
               </a:rPr>
-              <a:t>17</a:t>
+              <a:t>Voir →</a:t>
             </a:r>
           </a:p>
         </p:txBody>
@@ -29978,7 +29978,7 @@
                 </a:solidFill>
                 <a:latin typeface="Roboto"/>
               </a:rPr>
-              <a:t>18</a:t>
+              <a:t>Voir →</a:t>
             </a:r>
           </a:p>
         </p:txBody>
@@ -30131,7 +30131,7 @@
                 </a:solidFill>
                 <a:latin typeface="Roboto"/>
               </a:rPr>
-              <a:t>20</a:t>
+              <a:t>Voir →</a:t>
             </a:r>
           </a:p>
         </p:txBody>
@@ -30240,7 +30240,7 @@
                 </a:solidFill>
                 <a:latin typeface="Roboto"/>
               </a:rPr>
-              <a:t>21</a:t>
+              <a:t>Voir →</a:t>
             </a:r>
           </a:p>
         </p:txBody>
@@ -30479,7 +30479,7 @@
                 </a:solidFill>
                 <a:latin typeface="Roboto"/>
               </a:rPr>
-              <a:t>Page</a:t>
+              <a:t>Lien</a:t>
             </a:r>
           </a:p>
         </p:txBody>
@@ -30632,7 +30632,7 @@
                 </a:solidFill>
                 <a:latin typeface="Roboto"/>
               </a:rPr>
-              <a:t>22</a:t>
+              <a:t>Voir →</a:t>
             </a:r>
           </a:p>
         </p:txBody>
@@ -30741,7 +30741,7 @@
                 </a:solidFill>
                 <a:latin typeface="Roboto"/>
               </a:rPr>
-              <a:t>23</a:t>
+              <a:t>Voir →</a:t>
             </a:r>
           </a:p>
         </p:txBody>
@@ -30894,7 +30894,7 @@
                 </a:solidFill>
                 <a:latin typeface="Roboto"/>
               </a:rPr>
-              <a:t>25</a:t>
+              <a:t>Voir →</a:t>
             </a:r>
           </a:p>
         </p:txBody>
@@ -31003,7 +31003,7 @@
                 </a:solidFill>
                 <a:latin typeface="Roboto"/>
               </a:rPr>
-              <a:t>25</a:t>
+              <a:t>Voir →</a:t>
             </a:r>
           </a:p>
         </p:txBody>
@@ -31156,7 +31156,7 @@
                 </a:solidFill>
                 <a:latin typeface="Roboto"/>
               </a:rPr>
-              <a:t>28</a:t>
+              <a:t>Voir →</a:t>
             </a:r>
           </a:p>
         </p:txBody>
@@ -31265,7 +31265,7 @@
                 </a:solidFill>
                 <a:latin typeface="Roboto"/>
               </a:rPr>
-              <a:t>28</a:t>
+              <a:t>Voir →</a:t>
             </a:r>
           </a:p>
         </p:txBody>
@@ -31418,7 +31418,7 @@
                 </a:solidFill>
                 <a:latin typeface="Roboto"/>
               </a:rPr>
-              <a:t>29</a:t>
+              <a:t>Voir →</a:t>
             </a:r>
           </a:p>
         </p:txBody>
@@ -31527,7 +31527,7 @@
                 </a:solidFill>
                 <a:latin typeface="Roboto"/>
               </a:rPr>
-              <a:t>29</a:t>
+              <a:t>Voir →</a:t>
             </a:r>
           </a:p>
         </p:txBody>
@@ -31680,7 +31680,7 @@
                 </a:solidFill>
                 <a:latin typeface="Roboto"/>
               </a:rPr>
-              <a:t>33</a:t>
+              <a:t>Voir →</a:t>
             </a:r>
           </a:p>
         </p:txBody>
@@ -31789,7 +31789,7 @@
                 </a:solidFill>
                 <a:latin typeface="Roboto"/>
               </a:rPr>
-              <a:t>35</a:t>
+              <a:t>Voir →</a:t>
             </a:r>
           </a:p>
         </p:txBody>

</xml_diff>

<commit_message>
Document follower addition in the expert user manual
Add an "Ajouter un collègue au suivi" slide after "La carte de votre
équipe", with an annotated capture of the new block, list it in part 2's
divider, shift the hard-coded page numbers of the later dividers, and
mention followers in the "Qui reçoit quoi" annex.

Co-Authored-By: Claude Opus 5.5 <noreply@anthropic.com>
Claude-Session: https://claude.ai/code/session_01U1HFYwDkKFYcA74V4CPRa9
</commit_message>
<xml_diff>
--- a/docs/Manuel_Project_Navigator_expert.pptx
+++ b/docs/Manuel_Project_Navigator_expert.pptx
@@ -23,6 +23,7 @@
     <p:sldId id="265" r:id="rId22"/>
     <p:sldId id="266" r:id="rId23"/>
     <p:sldId id="267" r:id="rId24"/>
+    <p:sldId id="298" r:id="rId55"/>
     <p:sldId id="268" r:id="rId25"/>
     <p:sldId id="269" r:id="rId26"/>
     <p:sldId id="270" r:id="rId27"/>
@@ -11998,7 +11999,7 @@
                 </a:solidFill>
                 <a:latin typeface="Roboto"/>
               </a:rPr>
-              <a:t>15</a:t>
+              <a:t>16</a:t>
             </a:r>
           </a:p>
         </p:txBody>
@@ -12072,7 +12073,7 @@
                 </a:solidFill>
                 <a:latin typeface="Roboto"/>
               </a:rPr>
-              <a:t>16</a:t>
+              <a:t>17</a:t>
             </a:r>
           </a:p>
         </p:txBody>
@@ -12146,7 +12147,7 @@
                 </a:solidFill>
                 <a:latin typeface="Roboto"/>
               </a:rPr>
-              <a:t>17</a:t>
+              <a:t>18</a:t>
             </a:r>
           </a:p>
         </p:txBody>
@@ -12220,7 +12221,7 @@
                 </a:solidFill>
                 <a:latin typeface="Roboto"/>
               </a:rPr>
-              <a:t>18</a:t>
+              <a:t>19</a:t>
             </a:r>
           </a:p>
         </p:txBody>
@@ -15528,7 +15529,7 @@
                 </a:solidFill>
                 <a:latin typeface="Roboto"/>
               </a:rPr>
-              <a:t>20</a:t>
+              <a:t>21</a:t>
             </a:r>
           </a:p>
         </p:txBody>
@@ -15602,7 +15603,7 @@
                 </a:solidFill>
                 <a:latin typeface="Roboto"/>
               </a:rPr>
-              <a:t>21</a:t>
+              <a:t>22</a:t>
             </a:r>
           </a:p>
         </p:txBody>
@@ -15676,7 +15677,7 @@
                 </a:solidFill>
                 <a:latin typeface="Roboto"/>
               </a:rPr>
-              <a:t>22</a:t>
+              <a:t>23</a:t>
             </a:r>
           </a:p>
         </p:txBody>
@@ -15750,7 +15751,7 @@
                 </a:solidFill>
                 <a:latin typeface="Roboto"/>
               </a:rPr>
-              <a:t>23</a:t>
+              <a:t>24</a:t>
             </a:r>
           </a:p>
         </p:txBody>
@@ -19653,7 +19654,7 @@
                 </a:solidFill>
                 <a:latin typeface="Roboto"/>
               </a:rPr>
-              <a:t>25</a:t>
+              <a:t>26</a:t>
             </a:r>
           </a:p>
         </p:txBody>
@@ -20511,7 +20512,7 @@
                 </a:solidFill>
                 <a:latin typeface="Roboto"/>
               </a:rPr>
-              <a:t>27</a:t>
+              <a:t>28</a:t>
             </a:r>
           </a:p>
         </p:txBody>
@@ -20585,7 +20586,7 @@
                 </a:solidFill>
                 <a:latin typeface="Roboto"/>
               </a:rPr>
-              <a:t>28</a:t>
+              <a:t>29</a:t>
             </a:r>
           </a:p>
         </p:txBody>
@@ -20659,7 +20660,7 @@
                 </a:solidFill>
                 <a:latin typeface="Roboto"/>
               </a:rPr>
-              <a:t>29</a:t>
+              <a:t>30</a:t>
             </a:r>
           </a:p>
         </p:txBody>
@@ -20733,7 +20734,7 @@
                 </a:solidFill>
                 <a:latin typeface="Roboto"/>
               </a:rPr>
-              <a:t>30</a:t>
+              <a:t>31</a:t>
             </a:r>
           </a:p>
         </p:txBody>
@@ -20807,7 +20808,7 @@
                 </a:solidFill>
                 <a:latin typeface="Roboto"/>
               </a:rPr>
-              <a:t>31</a:t>
+              <a:t>32</a:t>
             </a:r>
           </a:p>
         </p:txBody>
@@ -20881,7 +20882,7 @@
                 </a:solidFill>
                 <a:latin typeface="Roboto"/>
               </a:rPr>
-              <a:t>32</a:t>
+              <a:t>33</a:t>
             </a:r>
           </a:p>
         </p:txBody>
@@ -20955,7 +20956,7 @@
                 </a:solidFill>
                 <a:latin typeface="Roboto"/>
               </a:rPr>
-              <a:t>34</a:t>
+              <a:t>35</a:t>
             </a:r>
           </a:p>
         </p:txBody>
@@ -21029,7 +21030,7 @@
                 </a:solidFill>
                 <a:latin typeface="Roboto"/>
               </a:rPr>
-              <a:t>35</a:t>
+              <a:t>36</a:t>
             </a:r>
           </a:p>
         </p:txBody>
@@ -21103,7 +21104,7 @@
                 </a:solidFill>
                 <a:latin typeface="Roboto"/>
               </a:rPr>
-              <a:t>36</a:t>
+              <a:t>37</a:t>
             </a:r>
           </a:p>
         </p:txBody>
@@ -33565,7 +33566,7 @@
                 </a:solidFill>
                 <a:latin typeface="Roboto"/>
               </a:rPr>
-              <a:t>Le référent si le projet est pris en charge, sinon les contacts de l’équipe.</a:t>
+              <a:t>Le référent et les collègues ajoutés au suivi si le projet est pris en charge, sinon les contacts de l’équipe.</a:t>
             </a:r>
           </a:p>
         </p:txBody>
@@ -35082,6 +35083,778 @@
                 <a:latin typeface="Roboto"/>
               </a:rPr>
               <a:t>Une question sur l’outil ? « Partagez votre avis », sur l’accueil.</a:t>
+            </a:r>
+          </a:p>
+        </p:txBody>
+      </p:sp>
+    </p:spTree>
+  </p:cSld>
+  <p:clrMapOvr>
+    <a:masterClrMapping/>
+  </p:clrMapOvr>
+</p:sld>
+</file>
+
+<file path=ppt/slides/slide43.xml><?xml version="1.0" encoding="utf-8"?>
+<p:sld xmlns:a="http://schemas.openxmlformats.org/drawingml/2006/main" xmlns:p="http://schemas.openxmlformats.org/presentationml/2006/main" xmlns:r="http://schemas.openxmlformats.org/officeDocument/2006/relationships">
+  <p:cSld>
+    <p:spTree>
+      <p:nvGrpSpPr>
+        <p:cNvPr id="1" name=""/>
+        <p:cNvGrpSpPr/>
+        <p:nvPr/>
+      </p:nvGrpSpPr>
+      <p:grpSpPr/>
+      <p:sp>
+        <p:nvSpPr>
+          <p:cNvPr id="2" name="Title 1"/>
+          <p:cNvSpPr>
+            <a:spLocks noGrp="1"/>
+          </p:cNvSpPr>
+          <p:nvPr>
+            <p:ph type="title"/>
+          </p:nvPr>
+        </p:nvSpPr>
+        <p:spPr/>
+        <p:txBody>
+          <a:bodyPr/>
+          <a:lstStyle/>
+          <a:p>
+            <a:r>
+              <a:t>Ajouter un collègue au suivi</a:t>
+            </a:r>
+          </a:p>
+        </p:txBody>
+      </p:sp>
+      <p:sp>
+        <p:nvSpPr>
+          <p:cNvPr id="3" name="Espace réservé du numéro de diapositive 2">
+            <a:extLst>
+              <a:ext uri="{FF2B5EF4-FFF2-40B4-BE49-F238E27FC236}">
+                <a16:creationId xmlns:a16="http://schemas.microsoft.com/office/drawing/2014/main" id="{81DB0728-04C4-DDCE-4F4A-D4EA08B4D65A}"/>
+              </a:ext>
+            </a:extLst>
+          </p:cNvPr>
+          <p:cNvSpPr>
+            <a:spLocks noGrp="1"/>
+          </p:cNvSpPr>
+          <p:nvPr>
+            <p:ph type="sldNum" sz="quarter" idx="10"/>
+          </p:nvPr>
+        </p:nvSpPr>
+        <p:spPr/>
+        <p:txBody>
+          <a:bodyPr/>
+          <a:lstStyle/>
+          <a:p>
+            <a:fld id="{B6F15528-21DE-4FAA-801E-634DDDAF4B2B}" type="slidenum">
+              <a:rPr lang="fr-FR" sz="800"/>
+              <a:t>‹N°›</a:t>
+            </a:fld>
+          </a:p>
+        </p:txBody>
+      </p:sp>
+      <p:sp>
+        <p:nvSpPr>
+          <p:cNvPr id="4" name="Espace réservé du pied de page 3">
+            <a:extLst>
+              <a:ext uri="{FF2B5EF4-FFF2-40B4-BE49-F238E27FC236}">
+                <a16:creationId xmlns:a16="http://schemas.microsoft.com/office/drawing/2014/main" id="{D77D12DE-AC0B-DC1C-8701-434038699D7A}"/>
+              </a:ext>
+            </a:extLst>
+          </p:cNvPr>
+          <p:cNvSpPr>
+            <a:spLocks noGrp="1"/>
+          </p:cNvSpPr>
+          <p:nvPr>
+            <p:ph type="ftr" sz="quarter" idx="11"/>
+          </p:nvPr>
+        </p:nvSpPr>
+        <p:spPr/>
+        <p:txBody>
+          <a:bodyPr/>
+          <a:lstStyle/>
+          <a:p>
+            <a:r>
+              <a:rPr lang="fr-FR" sz="800">
+                <a:latin typeface="Roboto"/>
+              </a:rPr>
+              <a:t>02 · Examiner un projet</a:t>
+            </a:r>
+          </a:p>
+        </p:txBody>
+      </p:sp>
+      <p:sp>
+        <p:nvSpPr>
+          <p:cNvPr id="5" name="TextBox 4">
+            <a:hlinkClick action="ppaction://hlinksldjump" r:id="rId4"/>
+          </p:cNvPr>
+          <p:cNvSpPr txBox="1"/>
+          <p:nvPr/>
+        </p:nvSpPr>
+        <p:spPr>
+          <a:xfrm>
+            <a:off x="7543800" y="164592"/>
+            <a:ext cx="1097280" cy="201168"/>
+          </a:xfrm>
+          <a:prstGeom prst="rect">
+            <a:avLst/>
+          </a:prstGeom>
+          <a:noFill/>
+        </p:spPr>
+        <p:txBody>
+          <a:bodyPr wrap="square" lIns="0" rIns="0" tIns="0" bIns="0" anchor="t">
+            <a:spAutoFit/>
+          </a:bodyPr>
+          <a:lstStyle/>
+          <a:p>
+            <a:pPr algn="r"/>
+            <a:r>
+              <a:rPr sz="800" b="0" i="0">
+                <a:solidFill>
+                  <a:srgbClr val="0061B0"/>
+                </a:solidFill>
+                <a:latin typeface="Roboto"/>
+              </a:rPr>
+              <a:t>← Sommaire</a:t>
+            </a:r>
+          </a:p>
+        </p:txBody>
+      </p:sp>
+      <p:pic>
+        <p:nvPicPr>
+          <p:cNvPr id="6" name="Picture 5" descr="Carte d’une équipe : bloc « Personnes qui suivent ce projet » avec un collègue ajouté et le menu « Ajouter au suivi »"/>
+          <p:cNvPicPr>
+            <a:picLocks noChangeAspect="1"/>
+          </p:cNvPicPr>
+          <p:nvPr/>
+        </p:nvPicPr>
+        <p:blipFill>
+          <a:blip r:embed="rId2"/>
+          <a:stretch>
+            <a:fillRect/>
+          </a:stretch>
+        </p:blipFill>
+        <p:spPr>
+          <a:xfrm>
+            <a:off x="548640" y="1188720"/>
+            <a:ext cx="4206240" cy="3181782"/>
+          </a:xfrm>
+          <a:prstGeom prst="rect">
+            <a:avLst/>
+          </a:prstGeom>
+          <a:ln w="9525">
+            <a:solidFill>
+              <a:srgbClr val="D5DCE4"/>
+            </a:solidFill>
+          </a:ln>
+        </p:spPr>
+      </p:pic>
+      <p:sp>
+        <p:nvSpPr>
+          <p:cNvPr id="7" name="Oval 6"/>
+          <p:cNvSpPr/>
+          <p:nvPr/>
+        </p:nvSpPr>
+        <p:spPr>
+          <a:xfrm>
+            <a:off x="4983480" y="1179576"/>
+            <a:ext cx="237744" cy="237744"/>
+          </a:xfrm>
+          <a:prstGeom prst="ellipse">
+            <a:avLst/>
+          </a:prstGeom>
+          <a:solidFill>
+            <a:srgbClr val="C8102E"/>
+          </a:solidFill>
+          <a:ln>
+            <a:noFill/>
+          </a:ln>
+          <a:effectLst/>
+        </p:spPr>
+        <p:style>
+          <a:lnRef idx="1">
+            <a:schemeClr val="accent1"/>
+          </a:lnRef>
+          <a:fillRef idx="3">
+            <a:schemeClr val="accent1"/>
+          </a:fillRef>
+          <a:effectRef idx="0">
+            <a:schemeClr val="accent1"/>
+          </a:effectRef>
+          <a:fontRef idx="minor">
+            <a:schemeClr val="lt1"/>
+          </a:fontRef>
+        </p:style>
+        <p:txBody>
+          <a:bodyPr rtlCol="0" anchor="ctr" lIns="0" rIns="0" tIns="0" bIns="0"/>
+          <a:lstStyle/>
+          <a:p>
+            <a:pPr algn="ctr"/>
+            <a:r>
+              <a:rPr lang="fr-FR" sz="1000" b="1">
+                <a:solidFill>
+                  <a:srgbClr val="FFFFFF"/>
+                </a:solidFill>
+                <a:latin typeface="Roboto"/>
+              </a:rPr>
+              <a:t>1</a:t>
+            </a:r>
+          </a:p>
+        </p:txBody>
+      </p:sp>
+      <p:sp>
+        <p:nvSpPr>
+          <p:cNvPr id="8" name="TextBox 7"/>
+          <p:cNvSpPr txBox="1"/>
+          <p:nvPr/>
+        </p:nvSpPr>
+        <p:spPr>
+          <a:xfrm>
+            <a:off x="5312664" y="1188720"/>
+            <a:ext cx="3282696" cy="292608"/>
+          </a:xfrm>
+          <a:prstGeom prst="rect">
+            <a:avLst/>
+          </a:prstGeom>
+          <a:noFill/>
+        </p:spPr>
+        <p:txBody>
+          <a:bodyPr wrap="square" lIns="0" rIns="0" tIns="0" bIns="0" anchor="t">
+            <a:spAutoFit/>
+          </a:bodyPr>
+          <a:lstStyle/>
+          <a:p>
+            <a:pPr algn="l"/>
+            <a:r>
+              <a:rPr lang="fr-FR" sz="900" b="1" i="0">
+                <a:solidFill>
+                  <a:srgbClr val="1F2A37"/>
+                </a:solidFill>
+                <a:latin typeface="Roboto"/>
+              </a:rPr>
+              <a:t>Ligne de contact </a:t>
+            </a:r>
+            <a:r>
+              <a:rPr lang="fr-FR" sz="900" b="0" i="0">
+                <a:solidFill>
+                  <a:srgbClr val="1F2A37"/>
+                </a:solidFill>
+                <a:latin typeface="Roboto"/>
+              </a:rPr>
+              <a:t>: le référent du projet, puis les collègues ajoutés au suivi.</a:t>
+            </a:r>
+          </a:p>
+        </p:txBody>
+      </p:sp>
+      <p:sp>
+        <p:nvSpPr>
+          <p:cNvPr id="9" name="Oval 8"/>
+          <p:cNvSpPr/>
+          <p:nvPr/>
+        </p:nvSpPr>
+        <p:spPr>
+          <a:xfrm>
+            <a:off x="4983480" y="1563624"/>
+            <a:ext cx="237744" cy="237744"/>
+          </a:xfrm>
+          <a:prstGeom prst="ellipse">
+            <a:avLst/>
+          </a:prstGeom>
+          <a:solidFill>
+            <a:srgbClr val="C8102E"/>
+          </a:solidFill>
+          <a:ln>
+            <a:noFill/>
+          </a:ln>
+          <a:effectLst/>
+        </p:spPr>
+        <p:style>
+          <a:lnRef idx="1">
+            <a:schemeClr val="accent1"/>
+          </a:lnRef>
+          <a:fillRef idx="3">
+            <a:schemeClr val="accent1"/>
+          </a:fillRef>
+          <a:effectRef idx="0">
+            <a:schemeClr val="accent1"/>
+          </a:effectRef>
+          <a:fontRef idx="minor">
+            <a:schemeClr val="lt1"/>
+          </a:fontRef>
+        </p:style>
+        <p:txBody>
+          <a:bodyPr rtlCol="0" anchor="ctr" lIns="0" rIns="0" tIns="0" bIns="0"/>
+          <a:lstStyle/>
+          <a:p>
+            <a:pPr algn="ctr"/>
+            <a:r>
+              <a:rPr lang="fr-FR" sz="1000" b="1">
+                <a:solidFill>
+                  <a:srgbClr val="FFFFFF"/>
+                </a:solidFill>
+                <a:latin typeface="Roboto"/>
+              </a:rPr>
+              <a:t>2</a:t>
+            </a:r>
+          </a:p>
+        </p:txBody>
+      </p:sp>
+      <p:sp>
+        <p:nvSpPr>
+          <p:cNvPr id="10" name="TextBox 9"/>
+          <p:cNvSpPr txBox="1"/>
+          <p:nvPr/>
+        </p:nvSpPr>
+        <p:spPr>
+          <a:xfrm>
+            <a:off x="5312664" y="1572768"/>
+            <a:ext cx="3282696" cy="292608"/>
+          </a:xfrm>
+          <a:prstGeom prst="rect">
+            <a:avLst/>
+          </a:prstGeom>
+          <a:noFill/>
+        </p:spPr>
+        <p:txBody>
+          <a:bodyPr wrap="square" lIns="0" rIns="0" tIns="0" bIns="0" anchor="t">
+            <a:spAutoFit/>
+          </a:bodyPr>
+          <a:lstStyle/>
+          <a:p>
+            <a:pPr algn="l"/>
+            <a:r>
+              <a:rPr lang="fr-FR" sz="900" b="1" i="0">
+                <a:solidFill>
+                  <a:srgbClr val="1F2A37"/>
+                </a:solidFill>
+                <a:latin typeface="Roboto"/>
+              </a:rPr>
+              <a:t>Personne ajoutée </a:t>
+            </a:r>
+            <a:r>
+              <a:rPr lang="fr-FR" sz="900" b="0" i="0">
+                <a:solidFill>
+                  <a:srgbClr val="1F2A37"/>
+                </a:solidFill>
+                <a:latin typeface="Roboto"/>
+              </a:rPr>
+              <a:t>: elle reçoit les notifications du projet pour votre équipe. Le « × » la retire du suivi.</a:t>
+            </a:r>
+          </a:p>
+        </p:txBody>
+      </p:sp>
+      <p:sp>
+        <p:nvSpPr>
+          <p:cNvPr id="11" name="Oval 10"/>
+          <p:cNvSpPr/>
+          <p:nvPr/>
+        </p:nvSpPr>
+        <p:spPr>
+          <a:xfrm>
+            <a:off x="4983480" y="1947672"/>
+            <a:ext cx="237744" cy="237744"/>
+          </a:xfrm>
+          <a:prstGeom prst="ellipse">
+            <a:avLst/>
+          </a:prstGeom>
+          <a:solidFill>
+            <a:srgbClr val="C8102E"/>
+          </a:solidFill>
+          <a:ln>
+            <a:noFill/>
+          </a:ln>
+          <a:effectLst/>
+        </p:spPr>
+        <p:style>
+          <a:lnRef idx="1">
+            <a:schemeClr val="accent1"/>
+          </a:lnRef>
+          <a:fillRef idx="3">
+            <a:schemeClr val="accent1"/>
+          </a:fillRef>
+          <a:effectRef idx="0">
+            <a:schemeClr val="accent1"/>
+          </a:effectRef>
+          <a:fontRef idx="minor">
+            <a:schemeClr val="lt1"/>
+          </a:fontRef>
+        </p:style>
+        <p:txBody>
+          <a:bodyPr rtlCol="0" anchor="ctr" lIns="0" rIns="0" tIns="0" bIns="0"/>
+          <a:lstStyle/>
+          <a:p>
+            <a:pPr algn="ctr"/>
+            <a:r>
+              <a:rPr lang="fr-FR" sz="1000" b="1">
+                <a:solidFill>
+                  <a:srgbClr val="FFFFFF"/>
+                </a:solidFill>
+                <a:latin typeface="Roboto"/>
+              </a:rPr>
+              <a:t>3</a:t>
+            </a:r>
+          </a:p>
+        </p:txBody>
+      </p:sp>
+      <p:sp>
+        <p:nvSpPr>
+          <p:cNvPr id="12" name="TextBox 11"/>
+          <p:cNvSpPr txBox="1"/>
+          <p:nvPr/>
+        </p:nvSpPr>
+        <p:spPr>
+          <a:xfrm>
+            <a:off x="5312664" y="1956816"/>
+            <a:ext cx="3282696" cy="438912"/>
+          </a:xfrm>
+          <a:prstGeom prst="rect">
+            <a:avLst/>
+          </a:prstGeom>
+          <a:noFill/>
+        </p:spPr>
+        <p:txBody>
+          <a:bodyPr wrap="square" lIns="0" rIns="0" tIns="0" bIns="0" anchor="t">
+            <a:spAutoFit/>
+          </a:bodyPr>
+          <a:lstStyle/>
+          <a:p>
+            <a:pPr algn="l"/>
+            <a:r>
+              <a:rPr lang="fr-FR" sz="900" b="1" i="0">
+                <a:solidFill>
+                  <a:srgbClr val="1F2A37"/>
+                </a:solidFill>
+                <a:latin typeface="Roboto"/>
+              </a:rPr>
+              <a:t>« Ajouter au suivi » </a:t>
+            </a:r>
+            <a:r>
+              <a:rPr lang="fr-FR" sz="900" b="0" i="0">
+                <a:solidFill>
+                  <a:srgbClr val="1F2A37"/>
+                </a:solidFill>
+                <a:latin typeface="Roboto"/>
+              </a:rPr>
+              <a:t>: choisissez un membre de l’équipe dans la liste, puis cliquez. Il est prévenu par e-mail.</a:t>
+            </a:r>
+          </a:p>
+        </p:txBody>
+      </p:sp>
+      <p:sp>
+        <p:nvSpPr>
+          <p:cNvPr id="13" name="Rounded Rectangle 12"/>
+          <p:cNvSpPr/>
+          <p:nvPr/>
+        </p:nvSpPr>
+        <p:spPr>
+          <a:xfrm>
+            <a:off x="4983480" y="2532888"/>
+            <a:ext cx="3611880" cy="1837632"/>
+          </a:xfrm>
+          <a:prstGeom prst="roundRect">
+            <a:avLst>
+              <a:gd name="adj" fmla="val 6000"/>
+            </a:avLst>
+          </a:prstGeom>
+          <a:solidFill>
+            <a:srgbClr val="EEF3F8"/>
+          </a:solidFill>
+          <a:ln>
+            <a:noFill/>
+          </a:ln>
+          <a:effectLst/>
+        </p:spPr>
+        <p:style>
+          <a:lnRef idx="1">
+            <a:schemeClr val="accent1"/>
+          </a:lnRef>
+          <a:fillRef idx="3">
+            <a:schemeClr val="accent1"/>
+          </a:fillRef>
+          <a:effectRef idx="0">
+            <a:schemeClr val="accent1"/>
+          </a:effectRef>
+          <a:fontRef idx="minor">
+            <a:schemeClr val="lt1"/>
+          </a:fontRef>
+        </p:style>
+        <p:txBody>
+          <a:bodyPr rtlCol="0" anchor="ctr"/>
+          <a:lstStyle/>
+          <a:p>
+            <a:pPr algn="ctr"/>
+          </a:p>
+        </p:txBody>
+      </p:sp>
+      <p:sp>
+        <p:nvSpPr>
+          <p:cNvPr id="14" name="TextBox 13"/>
+          <p:cNvSpPr txBox="1"/>
+          <p:nvPr/>
+        </p:nvSpPr>
+        <p:spPr>
+          <a:xfrm>
+            <a:off x="5129784" y="2734056"/>
+            <a:ext cx="3319272" cy="228600"/>
+          </a:xfrm>
+          <a:prstGeom prst="rect">
+            <a:avLst/>
+          </a:prstGeom>
+          <a:noFill/>
+        </p:spPr>
+        <p:txBody>
+          <a:bodyPr wrap="square" lIns="0" rIns="0" tIns="0" bIns="0" anchor="t">
+            <a:spAutoFit/>
+          </a:bodyPr>
+          <a:lstStyle/>
+          <a:p>
+            <a:pPr algn="l"/>
+            <a:r>
+              <a:rPr lang="fr-FR" sz="1000" b="1" i="0">
+                <a:solidFill>
+                  <a:srgbClr val="003059"/>
+                </a:solidFill>
+                <a:latin typeface="Roboto"/>
+              </a:rPr>
+              <a:t>Ce qu’il faut savoir</a:t>
+            </a:r>
+          </a:p>
+        </p:txBody>
+      </p:sp>
+      <p:sp>
+        <p:nvSpPr>
+          <p:cNvPr id="15" name="Oval 14"/>
+          <p:cNvSpPr/>
+          <p:nvPr/>
+        </p:nvSpPr>
+        <p:spPr>
+          <a:xfrm>
+            <a:off x="5129784" y="3059049"/>
+            <a:ext cx="73152" cy="73152"/>
+          </a:xfrm>
+          <a:prstGeom prst="ellipse">
+            <a:avLst/>
+          </a:prstGeom>
+          <a:solidFill>
+            <a:srgbClr val="0061B0"/>
+          </a:solidFill>
+          <a:ln>
+            <a:noFill/>
+          </a:ln>
+          <a:effectLst/>
+        </p:spPr>
+        <p:style>
+          <a:lnRef idx="1">
+            <a:schemeClr val="accent1"/>
+          </a:lnRef>
+          <a:fillRef idx="3">
+            <a:schemeClr val="accent1"/>
+          </a:fillRef>
+          <a:effectRef idx="0">
+            <a:schemeClr val="accent1"/>
+          </a:effectRef>
+          <a:fontRef idx="minor">
+            <a:schemeClr val="lt1"/>
+          </a:fontRef>
+        </p:style>
+        <p:txBody>
+          <a:bodyPr rtlCol="0" anchor="ctr"/>
+          <a:lstStyle/>
+          <a:p>
+            <a:pPr algn="ctr"/>
+          </a:p>
+        </p:txBody>
+      </p:sp>
+      <p:sp>
+        <p:nvSpPr>
+          <p:cNvPr id="16" name="TextBox 15"/>
+          <p:cNvSpPr txBox="1"/>
+          <p:nvPr/>
+        </p:nvSpPr>
+        <p:spPr>
+          <a:xfrm>
+            <a:off x="5312664" y="3008376"/>
+            <a:ext cx="3136392" cy="308864"/>
+          </a:xfrm>
+          <a:prstGeom prst="rect">
+            <a:avLst/>
+          </a:prstGeom>
+          <a:noFill/>
+        </p:spPr>
+        <p:txBody>
+          <a:bodyPr wrap="square" lIns="0" rIns="0" tIns="0" bIns="0" anchor="t">
+            <a:spAutoFit/>
+          </a:bodyPr>
+          <a:lstStyle/>
+          <a:p>
+            <a:pPr algn="l"/>
+            <a:r>
+              <a:rPr lang="fr-FR" sz="950" b="0" i="0">
+                <a:solidFill>
+                  <a:srgbClr val="1F2A37"/>
+                </a:solidFill>
+                <a:latin typeface="Roboto"/>
+              </a:rPr>
+              <a:t>Seuls les contacts de votre équipe peuvent être ajoutés : ils peuvent déjà répondre et rendre l’avis.</a:t>
+            </a:r>
+          </a:p>
+        </p:txBody>
+      </p:sp>
+      <p:sp>
+        <p:nvSpPr>
+          <p:cNvPr id="17" name="Oval 16"/>
+          <p:cNvSpPr/>
+          <p:nvPr/>
+        </p:nvSpPr>
+        <p:spPr>
+          <a:xfrm>
+            <a:off x="5129784" y="3441065"/>
+            <a:ext cx="73152" cy="73152"/>
+          </a:xfrm>
+          <a:prstGeom prst="ellipse">
+            <a:avLst/>
+          </a:prstGeom>
+          <a:solidFill>
+            <a:srgbClr val="0061B0"/>
+          </a:solidFill>
+          <a:ln>
+            <a:noFill/>
+          </a:ln>
+          <a:effectLst/>
+        </p:spPr>
+        <p:style>
+          <a:lnRef idx="1">
+            <a:schemeClr val="accent1"/>
+          </a:lnRef>
+          <a:fillRef idx="3">
+            <a:schemeClr val="accent1"/>
+          </a:fillRef>
+          <a:effectRef idx="0">
+            <a:schemeClr val="accent1"/>
+          </a:effectRef>
+          <a:fontRef idx="minor">
+            <a:schemeClr val="lt1"/>
+          </a:fontRef>
+        </p:style>
+        <p:txBody>
+          <a:bodyPr rtlCol="0" anchor="ctr"/>
+          <a:lstStyle/>
+          <a:p>
+            <a:pPr algn="ctr"/>
+          </a:p>
+        </p:txBody>
+      </p:sp>
+      <p:sp>
+        <p:nvSpPr>
+          <p:cNvPr id="18" name="TextBox 17"/>
+          <p:cNvSpPr txBox="1"/>
+          <p:nvPr/>
+        </p:nvSpPr>
+        <p:spPr>
+          <a:xfrm>
+            <a:off x="5312664" y="3390392"/>
+            <a:ext cx="3136392" cy="463296"/>
+          </a:xfrm>
+          <a:prstGeom prst="rect">
+            <a:avLst/>
+          </a:prstGeom>
+          <a:noFill/>
+        </p:spPr>
+        <p:txBody>
+          <a:bodyPr wrap="square" lIns="0" rIns="0" tIns="0" bIns="0" anchor="t">
+            <a:spAutoFit/>
+          </a:bodyPr>
+          <a:lstStyle/>
+          <a:p>
+            <a:pPr algn="l"/>
+            <a:r>
+              <a:rPr lang="fr-FR" sz="950" b="0" i="0">
+                <a:solidFill>
+                  <a:srgbClr val="1F2A37"/>
+                </a:solidFill>
+                <a:latin typeface="Roboto"/>
+              </a:rPr>
+              <a:t>Même si un collègue a pris le projet en charge, la personne ajoutée reste destinataire des échanges et garde le projet dans « À traiter ».</a:t>
+            </a:r>
+          </a:p>
+        </p:txBody>
+      </p:sp>
+      <p:sp>
+        <p:nvSpPr>
+          <p:cNvPr id="19" name="Oval 18"/>
+          <p:cNvSpPr/>
+          <p:nvPr/>
+        </p:nvSpPr>
+        <p:spPr>
+          <a:xfrm>
+            <a:off x="5129784" y="3977513"/>
+            <a:ext cx="73152" cy="73152"/>
+          </a:xfrm>
+          <a:prstGeom prst="ellipse">
+            <a:avLst/>
+          </a:prstGeom>
+          <a:solidFill>
+            <a:srgbClr val="0061B0"/>
+          </a:solidFill>
+          <a:ln>
+            <a:noFill/>
+          </a:ln>
+          <a:effectLst/>
+        </p:spPr>
+        <p:style>
+          <a:lnRef idx="1">
+            <a:schemeClr val="accent1"/>
+          </a:lnRef>
+          <a:fillRef idx="3">
+            <a:schemeClr val="accent1"/>
+          </a:fillRef>
+          <a:effectRef idx="0">
+            <a:schemeClr val="accent1"/>
+          </a:effectRef>
+          <a:fontRef idx="minor">
+            <a:schemeClr val="lt1"/>
+          </a:fontRef>
+        </p:style>
+        <p:txBody>
+          <a:bodyPr rtlCol="0" anchor="ctr"/>
+          <a:lstStyle/>
+          <a:p>
+            <a:pPr algn="ctr"/>
+          </a:p>
+        </p:txBody>
+      </p:sp>
+      <p:sp>
+        <p:nvSpPr>
+          <p:cNvPr id="20" name="TextBox 19"/>
+          <p:cNvSpPr txBox="1"/>
+          <p:nvPr/>
+        </p:nvSpPr>
+        <p:spPr>
+          <a:xfrm>
+            <a:off x="5312664" y="3926840"/>
+            <a:ext cx="3136392" cy="154432"/>
+          </a:xfrm>
+          <a:prstGeom prst="rect">
+            <a:avLst/>
+          </a:prstGeom>
+          <a:noFill/>
+        </p:spPr>
+        <p:txBody>
+          <a:bodyPr wrap="square" lIns="0" rIns="0" tIns="0" bIns="0" anchor="t">
+            <a:spAutoFit/>
+          </a:bodyPr>
+          <a:lstStyle/>
+          <a:p>
+            <a:pPr algn="l"/>
+            <a:r>
+              <a:rPr lang="fr-FR" sz="950" b="0" i="0">
+                <a:solidFill>
+                  <a:srgbClr val="1F2A37"/>
+                </a:solidFill>
+                <a:latin typeface="Roboto"/>
+              </a:rPr>
+              <a:t>Retirer quelqu’un du suivi n’envoie aucun e-mail.</a:t>
             </a:r>
           </a:p>
         </p:txBody>
@@ -38292,6 +39065,80 @@
       </p:sp>
       <p:sp>
         <p:nvSpPr>
+          <p:cNvPr id="15" name="TextBox 14">
+            <a:hlinkClick action="ppaction://hlinksldjump" r:id="rId8"/>
+          </p:cNvPr>
+          <p:cNvSpPr txBox="1"/>
+          <p:nvPr/>
+        </p:nvSpPr>
+        <p:spPr>
+          <a:xfrm>
+            <a:off x="6629400" y="2364231"/>
+            <a:ext cx="1691640" cy="329184"/>
+          </a:xfrm>
+          <a:prstGeom prst="rect">
+            <a:avLst/>
+          </a:prstGeom>
+          <a:noFill/>
+        </p:spPr>
+        <p:txBody>
+          <a:bodyPr wrap="square" lIns="0" rIns="0" tIns="0" bIns="0" anchor="t">
+            <a:spAutoFit/>
+          </a:bodyPr>
+          <a:lstStyle/>
+          <a:p>
+            <a:pPr algn="l"/>
+            <a:r>
+              <a:rPr sz="950" b="0" i="0">
+                <a:solidFill>
+                  <a:srgbClr val="003059"/>
+                </a:solidFill>
+                <a:latin typeface="Roboto"/>
+              </a:rPr>
+              <a:t>Ajouter un collègue au suivi</a:t>
+            </a:r>
+          </a:p>
+        </p:txBody>
+      </p:sp>
+      <p:sp>
+        <p:nvSpPr>
+          <p:cNvPr id="16" name="TextBox 15">
+            <a:hlinkClick action="ppaction://hlinksldjump" r:id="rId8"/>
+          </p:cNvPr>
+          <p:cNvSpPr txBox="1"/>
+          <p:nvPr/>
+        </p:nvSpPr>
+        <p:spPr>
+          <a:xfrm>
+            <a:off x="8321040" y="2364231"/>
+            <a:ext cx="320040" cy="182880"/>
+          </a:xfrm>
+          <a:prstGeom prst="rect">
+            <a:avLst/>
+          </a:prstGeom>
+          <a:noFill/>
+        </p:spPr>
+        <p:txBody>
+          <a:bodyPr wrap="square" lIns="0" rIns="0" tIns="0" bIns="0" anchor="t">
+            <a:spAutoFit/>
+          </a:bodyPr>
+          <a:lstStyle/>
+          <a:p>
+            <a:pPr algn="r"/>
+            <a:r>
+              <a:rPr sz="950" b="1" i="0">
+                <a:solidFill>
+                  <a:srgbClr val="996B14"/>
+                </a:solidFill>
+                <a:latin typeface="Roboto"/>
+              </a:rPr>
+              <a:t>13</a:t>
+            </a:r>
+          </a:p>
+        </p:txBody>
+      </p:sp>
+      <p:sp>
+        <p:nvSpPr>
           <p:cNvPr id="13" name="TextBox 12">
             <a:hlinkClick action="ppaction://hlinksldjump" r:id="rId7"/>
           </p:cNvPr>
@@ -38300,7 +39147,7 @@
         </p:nvSpPr>
         <p:spPr>
           <a:xfrm>
-            <a:off x="6629400" y="2364231"/>
+            <a:off x="6629400" y="2628390"/>
             <a:ext cx="1691640" cy="329184"/>
           </a:xfrm>
           <a:prstGeom prst="rect">
@@ -38337,7 +39184,7 @@
         </p:nvSpPr>
         <p:spPr>
           <a:xfrm>
-            <a:off x="8321040" y="2364231"/>
+            <a:off x="8321040" y="2628390"/>
             <a:ext cx="320040" cy="182880"/>
           </a:xfrm>
           <a:prstGeom prst="rect">
@@ -38359,7 +39206,7 @@
                 </a:solidFill>
                 <a:latin typeface="Roboto"/>
               </a:rPr>
-              <a:t>13</a:t>
+              <a:t>14</a:t>
             </a:r>
           </a:p>
         </p:txBody>

</xml_diff>